<commit_message>
Second test on 168 Belgian/German photos by season, CLIP baseline comparison
</commit_message>
<xml_diff>
--- a/slides.pptx
+++ b/slides.pptx
@@ -3675,7 +3675,7 @@
               </a:defRPr>
             </a:pPr>
             <a:r>
-              <a:t>• Why not Google Lens? It gives a species name and stops. Ours answers 'should I report this?' and was tested on the look-alikes</a:t>
+              <a:t>• Why not a general AI model? We tested one (CLIP): same knotweed found, but 4x more false alarms</a:t>
             </a:r>
           </a:p>
         </p:txBody>
@@ -3909,7 +3909,7 @@
               </a:defRPr>
             </a:pPr>
             <a:r>
-              <a:t>Results on 73 photos it never saw</a:t>
+              <a:t>Results on photos it never saw</a:t>
             </a:r>
           </a:p>
         </p:txBody>
@@ -3947,7 +3947,7 @@
               </a:defRPr>
             </a:pPr>
             <a:r>
-              <a:t>• 95% right overall (but always saying 'no' would already score 64%)</a:t>
+              <a:t>• 73 Dutch test photos: 95% right · 24 of 26 knotweed found · 2 of 47 false alarms</a:t>
             </a:r>
           </a:p>
           <a:p>
@@ -3962,7 +3962,7 @@
               </a:defRPr>
             </a:pPr>
             <a:r>
-              <a:t>• Found 24 of 26 knotweed photos</a:t>
+              <a:t>• 168 new photos from Belgium and Germany, all seasons: 93% right · 77 of 83 found · 5 of 85 false alarms</a:t>
             </a:r>
           </a:p>
           <a:p>
@@ -3977,7 +3977,7 @@
               </a:defRPr>
             </a:pPr>
             <a:r>
-              <a:t>• Wrongly flagged 2 of 47 other plants</a:t>
+              <a:t>• Spring 93% · summer 93% · autumn/winter 95%: spring shoots are only slightly harder</a:t>
             </a:r>
           </a:p>
           <a:p>
@@ -3992,7 +3992,22 @@
               </a:defRPr>
             </a:pPr>
             <a:r>
-              <a:t>• Both misses: young spring shoots (April, May)</a:t>
+              <a:t>• General AI model (CLIP), same 168 photos: 84% · 77 of 83 found · 21 of 85 false alarms</a:t>
+            </a:r>
+          </a:p>
+          <a:p>
+            <a:pPr>
+              <a:spcAft>
+                <a:spcPts val="1000"/>
+              </a:spcAft>
+              <a:defRPr sz="2200" b="0">
+                <a:solidFill>
+                  <a:srgbClr val="222222"/>
+                </a:solidFill>
+              </a:defRPr>
+            </a:pPr>
+            <a:r>
+              <a:t>• Our model: 4x fewer false alarms than the general model, which could mean fewer unnecessary checks</a:t>
             </a:r>
           </a:p>
           <a:p>
@@ -4131,7 +4146,7 @@
               </a:defRPr>
             </a:pPr>
             <a:r>
-              <a:t>• What we did: 70% threshold with a 'maybe' zone; the app never tells you to remove anything, only to report it</a:t>
+              <a:t>• What we did: 70% threshold with a 'maybe' zone; the app never tells you to remove anything, only to report it; tested on a second, independent set</a:t>
             </a:r>
           </a:p>
           <a:p>
@@ -4176,7 +4191,7 @@
               </a:defRPr>
             </a:pPr>
             <a:r>
-              <a:t>• Next: test on our own spring photos; add spring and winter images</a:t>
+              <a:t>• Next: test on our own street photos; add winter images</a:t>
             </a:r>
           </a:p>
         </p:txBody>
@@ -4300,7 +4315,22 @@
               </a:defRPr>
             </a:pPr>
             <a:r>
-              <a:t>• Learned: a high score can hide the mistakes that matter; count the misses</a:t>
+              <a:t>• Learned: a high score can hide the mistakes that matter; count the misses and false alarms</a:t>
+            </a:r>
+          </a:p>
+          <a:p>
+            <a:pPr>
+              <a:spcAft>
+                <a:spcPts val="1000"/>
+              </a:spcAft>
+              <a:defRPr sz="2200" b="0">
+                <a:solidFill>
+                  <a:srgbClr val="222222"/>
+                </a:solidFill>
+              </a:defRPr>
+            </a:pPr>
+            <a:r>
+              <a:t>• Learned: our guess that spring would be much worse was wrong; testing beat guessing</a:t>
             </a:r>
           </a:p>
           <a:p>

</xml_diff>

<commit_message>
Add what surprised us
</commit_message>
<xml_diff>
--- a/slides.pptx
+++ b/slides.pptx
@@ -4330,22 +4330,7 @@
               </a:defRPr>
             </a:pPr>
             <a:r>
-              <a:t>• Learned: our guess that spring would be much worse was wrong; testing beat guessing</a:t>
-            </a:r>
-          </a:p>
-          <a:p>
-            <a:pPr>
-              <a:spcAft>
-                <a:spcPts val="1000"/>
-              </a:spcAft>
-              <a:defRPr sz="2200" b="0">
-                <a:solidFill>
-                  <a:srgbClr val="222222"/>
-                </a:solidFill>
-              </a:defRPr>
-            </a:pPr>
-            <a:r>
-              <a:t>• What surprised us: OUR_OWN_LESSON</a:t>
+              <a:t>• What surprised us: We expected the model to fail on young spring shoots, but when we tested it on 168 new photos from Belgium and Germany it found 27 of 30 spring plants. The real problem was somewhere else: iNaturalist's search had mixed up knotweed and bindweed, so about 70 of our photos had the wrong label before we caught it. Testing taught us more than guessing.</a:t>
             </a:r>
           </a:p>
         </p:txBody>

</xml_diff>